<commit_message>
Deck refresh: 2026 preseason FPI era + backtest slide
Upset Board slide shows the live 5-alert board under the ESPN 2026
prior (incl. the flipped-line data-bug catch); new backtest slide
(1,147 alerts, 49.7% ATS, worst on big edges); Season Sim chart
re-run on the 2026 prior (ND 11.1 leads); workbook tour and roadmap
updated. Now 10 slides.

Co-Authored-By: Claude Fable 5 <noreply@anthropic.com>
</commit_message>
<xml_diff>
--- a/NCAA_FBS_Analytics_System.pptx
+++ b/NCAA_FBS_Analytics_System.pptx
@@ -14,6 +14,7 @@
     <p:sldId id="262" r:id="rId13"/>
     <p:sldId id="263" r:id="rId14"/>
     <p:sldId id="264" r:id="rId15"/>
+    <p:sldId id="265" r:id="rId16"/>
   </p:sldIdLst>
   <p:sldSz cx="12191695" cy="6858000" type="screen4x3"/>
   <p:notesSz cx="6858000" cy="9144000"/>
@@ -320,19 +321,19 @@
               <c:strCache>
                 <c:ptCount val="8"/>
                 <c:pt idx="0">
+                  <c:v>Notre Dame</c:v>
+                </c:pt>
+                <c:pt idx="1">
                   <c:v>Texas Tech</c:v>
                 </c:pt>
-                <c:pt idx="1">
-                  <c:v>Indiana</c:v>
-                </c:pt>
                 <c:pt idx="2">
-                  <c:v>Notre Dame</c:v>
+                  <c:v>Oregon</c:v>
                 </c:pt>
                 <c:pt idx="3">
                   <c:v>Miami</c:v>
                 </c:pt>
                 <c:pt idx="4">
-                  <c:v>James Madison</c:v>
+                  <c:v>Indiana</c:v>
                 </c:pt>
                 <c:pt idx="5">
                   <c:v>Ohio State</c:v>
@@ -341,7 +342,7 @@
                   <c:v>Georgia</c:v>
                 </c:pt>
                 <c:pt idx="7">
-                  <c:v>Oregon</c:v>
+                  <c:v>Texas</c:v>
                 </c:pt>
               </c:strCache>
             </c:strRef>
@@ -353,28 +354,28 @@
                 <c:formatCode>General</c:formatCode>
                 <c:ptCount val="8"/>
                 <c:pt idx="0">
-                  <c:v>11.2</c:v>
+                  <c:v>11.1</c:v>
                 </c:pt>
                 <c:pt idx="1">
-                  <c:v>11.1</c:v>
+                  <c:v>10.7</c:v>
                 </c:pt>
                 <c:pt idx="2">
-                  <c:v>11.1</c:v>
+                  <c:v>10.3</c:v>
                 </c:pt>
                 <c:pt idx="3">
-                  <c:v>10.6</c:v>
+                  <c:v>10.2</c:v>
                 </c:pt>
                 <c:pt idx="4">
-                  <c:v>10.6</c:v>
+                  <c:v>10.2</c:v>
                 </c:pt>
                 <c:pt idx="5">
-                  <c:v>10.4</c:v>
+                  <c:v>10.1</c:v>
                 </c:pt>
                 <c:pt idx="6">
-                  <c:v>10.2</c:v>
+                  <c:v>10.1</c:v>
                 </c:pt>
                 <c:pt idx="7">
-                  <c:v>10.1</c:v>
+                  <c:v>9.7</c:v>
                 </c:pt>
               </c:numCache>
             </c:numRef>
@@ -3648,6 +3649,488 @@
 </p:sld>
 </file>
 
+<file path=ppt/slides/slide10.xml><?xml version="1.0" encoding="utf-8"?>
+<p:sld xmlns:a="http://schemas.openxmlformats.org/drawingml/2006/main" xmlns:p="http://schemas.openxmlformats.org/presentationml/2006/main" xmlns:r="http://schemas.openxmlformats.org/officeDocument/2006/relationships">
+  <p:cSld>
+    <p:spTree>
+      <p:nvGrpSpPr>
+        <p:cNvPr id="1" name=""/>
+        <p:cNvGrpSpPr/>
+        <p:nvPr/>
+      </p:nvGrpSpPr>
+      <p:grpSpPr/>
+      <p:sp>
+        <p:nvSpPr>
+          <p:cNvPr id="2" name="Rectangle 1"/>
+          <p:cNvSpPr/>
+          <p:nvPr/>
+        </p:nvSpPr>
+        <p:spPr>
+          <a:xfrm>
+            <a:off x="0" y="0"/>
+            <a:ext cx="12191695" cy="6858000"/>
+          </a:xfrm>
+          <a:prstGeom prst="rect">
+            <a:avLst/>
+          </a:prstGeom>
+          <a:solidFill>
+            <a:srgbClr val="0A2851"/>
+          </a:solidFill>
+          <a:ln>
+            <a:noFill/>
+          </a:ln>
+          <a:effectLst/>
+        </p:spPr>
+        <p:style>
+          <a:lnRef idx="1">
+            <a:schemeClr val="accent1"/>
+          </a:lnRef>
+          <a:fillRef idx="3">
+            <a:schemeClr val="accent1"/>
+          </a:fillRef>
+          <a:effectRef idx="2">
+            <a:schemeClr val="accent1"/>
+          </a:effectRef>
+          <a:fontRef idx="minor">
+            <a:schemeClr val="lt1"/>
+          </a:fontRef>
+        </p:style>
+        <p:txBody>
+          <a:bodyPr rtlCol="0" anchor="ctr"/>
+          <a:lstStyle/>
+          <a:p>
+            <a:pPr algn="ctr"/>
+          </a:p>
+        </p:txBody>
+      </p:sp>
+      <p:sp>
+        <p:nvSpPr>
+          <p:cNvPr id="3" name="TextBox 2"/>
+          <p:cNvSpPr txBox="1"/>
+          <p:nvPr/>
+        </p:nvSpPr>
+        <p:spPr>
+          <a:xfrm>
+            <a:off x="822960" y="640080"/>
+            <a:ext cx="10515600" cy="822960"/>
+          </a:xfrm>
+          <a:prstGeom prst="rect">
+            <a:avLst/>
+          </a:prstGeom>
+          <a:noFill/>
+        </p:spPr>
+        <p:txBody>
+          <a:bodyPr wrap="square" anchor="t" lIns="0" rIns="0" tIns="0" bIns="0">
+            <a:spAutoFit/>
+          </a:bodyPr>
+          <a:lstStyle/>
+          <a:p>
+            <a:pPr algn="l">
+              <a:lnSpc>
+                <a:spcPct val="100000"/>
+              </a:lnSpc>
+              <a:spcAft>
+                <a:spcPts val="600"/>
+              </a:spcAft>
+            </a:pPr>
+            <a:r>
+              <a:rPr sz="3600" b="1" i="0">
+                <a:solidFill>
+                  <a:srgbClr val="FFFFFF"/>
+                </a:solidFill>
+                <a:latin typeface="Arial"/>
+              </a:rPr>
+              <a:t>What's Next</a:t>
+            </a:r>
+          </a:p>
+        </p:txBody>
+      </p:sp>
+      <p:sp>
+        <p:nvSpPr>
+          <p:cNvPr id="4" name="TextBox 3"/>
+          <p:cNvSpPr txBox="1"/>
+          <p:nvPr/>
+        </p:nvSpPr>
+        <p:spPr>
+          <a:xfrm>
+            <a:off x="822960" y="1828800"/>
+            <a:ext cx="2377440" cy="548640"/>
+          </a:xfrm>
+          <a:prstGeom prst="rect">
+            <a:avLst/>
+          </a:prstGeom>
+          <a:noFill/>
+        </p:spPr>
+        <p:txBody>
+          <a:bodyPr wrap="square" anchor="t" lIns="0" rIns="0" tIns="0" bIns="0">
+            <a:spAutoFit/>
+          </a:bodyPr>
+          <a:lstStyle/>
+          <a:p>
+            <a:pPr algn="l">
+              <a:lnSpc>
+                <a:spcPct val="100000"/>
+              </a:lnSpc>
+              <a:spcAft>
+                <a:spcPts val="600"/>
+              </a:spcAft>
+            </a:pPr>
+            <a:r>
+              <a:rPr sz="1700" b="1" i="0">
+                <a:solidFill>
+                  <a:srgbClr val="F47321"/>
+                </a:solidFill>
+                <a:latin typeface="Arial"/>
+              </a:rPr>
+              <a:t>Done — July 14</a:t>
+            </a:r>
+          </a:p>
+        </p:txBody>
+      </p:sp>
+      <p:sp>
+        <p:nvSpPr>
+          <p:cNvPr id="5" name="TextBox 4"/>
+          <p:cNvSpPr txBox="1"/>
+          <p:nvPr/>
+        </p:nvSpPr>
+        <p:spPr>
+          <a:xfrm>
+            <a:off x="3383280" y="1828800"/>
+            <a:ext cx="7955279" cy="822960"/>
+          </a:xfrm>
+          <a:prstGeom prst="rect">
+            <a:avLst/>
+          </a:prstGeom>
+          <a:noFill/>
+        </p:spPr>
+        <p:txBody>
+          <a:bodyPr wrap="square" anchor="t" lIns="0" rIns="0" tIns="0" bIns="0">
+            <a:spAutoFit/>
+          </a:bodyPr>
+          <a:lstStyle/>
+          <a:p>
+            <a:pPr algn="l">
+              <a:lnSpc>
+                <a:spcPct val="100000"/>
+              </a:lnSpc>
+              <a:spcAft>
+                <a:spcPts val="600"/>
+              </a:spcAft>
+            </a:pPr>
+            <a:r>
+              <a:rPr sz="1500" b="0" i="0">
+                <a:solidFill>
+                  <a:srgbClr val="CADCFC"/>
+                </a:solidFill>
+                <a:latin typeface="Arial"/>
+              </a:rPr>
+              <a:t>ESPN 2026 preseason FPI captured (from ESPN's API, ahead of CFBD) and wired through alerts, sim, and schedules</a:t>
+            </a:r>
+          </a:p>
+        </p:txBody>
+      </p:sp>
+      <p:sp>
+        <p:nvSpPr>
+          <p:cNvPr id="6" name="TextBox 5"/>
+          <p:cNvSpPr txBox="1"/>
+          <p:nvPr/>
+        </p:nvSpPr>
+        <p:spPr>
+          <a:xfrm>
+            <a:off x="822960" y="2788920"/>
+            <a:ext cx="2377440" cy="548640"/>
+          </a:xfrm>
+          <a:prstGeom prst="rect">
+            <a:avLst/>
+          </a:prstGeom>
+          <a:noFill/>
+        </p:spPr>
+        <p:txBody>
+          <a:bodyPr wrap="square" anchor="t" lIns="0" rIns="0" tIns="0" bIns="0">
+            <a:spAutoFit/>
+          </a:bodyPr>
+          <a:lstStyle/>
+          <a:p>
+            <a:pPr algn="l">
+              <a:lnSpc>
+                <a:spcPct val="100000"/>
+              </a:lnSpc>
+              <a:spcAft>
+                <a:spcPts val="600"/>
+              </a:spcAft>
+            </a:pPr>
+            <a:r>
+              <a:rPr sz="1700" b="1" i="0">
+                <a:solidFill>
+                  <a:srgbClr val="F47321"/>
+                </a:solidFill>
+                <a:latin typeface="Arial"/>
+              </a:rPr>
+              <a:t>August</a:t>
+            </a:r>
+          </a:p>
+        </p:txBody>
+      </p:sp>
+      <p:sp>
+        <p:nvSpPr>
+          <p:cNvPr id="7" name="TextBox 6"/>
+          <p:cNvSpPr txBox="1"/>
+          <p:nvPr/>
+        </p:nvSpPr>
+        <p:spPr>
+          <a:xfrm>
+            <a:off x="3383280" y="2788920"/>
+            <a:ext cx="7955279" cy="822960"/>
+          </a:xfrm>
+          <a:prstGeom prst="rect">
+            <a:avLst/>
+          </a:prstGeom>
+          <a:noFill/>
+        </p:spPr>
+        <p:txBody>
+          <a:bodyPr wrap="square" anchor="t" lIns="0" rIns="0" tIns="0" bIns="0">
+            <a:spAutoFit/>
+          </a:bodyPr>
+          <a:lstStyle/>
+          <a:p>
+            <a:pPr algn="l">
+              <a:lnSpc>
+                <a:spcPct val="100000"/>
+              </a:lnSpc>
+              <a:spcAft>
+                <a:spcPts val="600"/>
+              </a:spcAft>
+            </a:pPr>
+            <a:r>
+              <a:rPr sz="1500" b="0" i="0">
+                <a:solidFill>
+                  <a:srgbClr val="CADCFC"/>
+                </a:solidFill>
+                <a:latin typeface="Arial"/>
+              </a:rPr>
+              <a:t>true preseason decomposition — regress ESPN's 2026 numbers on 2026 public inputs the moment CFBD mirrors them</a:t>
+            </a:r>
+          </a:p>
+        </p:txBody>
+      </p:sp>
+      <p:sp>
+        <p:nvSpPr>
+          <p:cNvPr id="8" name="TextBox 7"/>
+          <p:cNvSpPr txBox="1"/>
+          <p:nvPr/>
+        </p:nvSpPr>
+        <p:spPr>
+          <a:xfrm>
+            <a:off x="822960" y="3749039"/>
+            <a:ext cx="2377440" cy="548640"/>
+          </a:xfrm>
+          <a:prstGeom prst="rect">
+            <a:avLst/>
+          </a:prstGeom>
+          <a:noFill/>
+        </p:spPr>
+        <p:txBody>
+          <a:bodyPr wrap="square" anchor="t" lIns="0" rIns="0" tIns="0" bIns="0">
+            <a:spAutoFit/>
+          </a:bodyPr>
+          <a:lstStyle/>
+          <a:p>
+            <a:pPr algn="l">
+              <a:lnSpc>
+                <a:spcPct val="100000"/>
+              </a:lnSpc>
+              <a:spcAft>
+                <a:spcPts val="600"/>
+              </a:spcAft>
+            </a:pPr>
+            <a:r>
+              <a:rPr sz="1700" b="1" i="0">
+                <a:solidFill>
+                  <a:srgbClr val="F47321"/>
+                </a:solidFill>
+                <a:latin typeface="Arial"/>
+              </a:rPr>
+              <a:t>Weekly in-season</a:t>
+            </a:r>
+          </a:p>
+        </p:txBody>
+      </p:sp>
+      <p:sp>
+        <p:nvSpPr>
+          <p:cNvPr id="9" name="TextBox 8"/>
+          <p:cNvSpPr txBox="1"/>
+          <p:nvPr/>
+        </p:nvSpPr>
+        <p:spPr>
+          <a:xfrm>
+            <a:off x="3383280" y="3749039"/>
+            <a:ext cx="7955279" cy="822960"/>
+          </a:xfrm>
+          <a:prstGeom prst="rect">
+            <a:avLst/>
+          </a:prstGeom>
+          <a:noFill/>
+        </p:spPr>
+        <p:txBody>
+          <a:bodyPr wrap="square" anchor="t" lIns="0" rIns="0" tIns="0" bIns="0">
+            <a:spAutoFit/>
+          </a:bodyPr>
+          <a:lstStyle/>
+          <a:p>
+            <a:pPr algn="l">
+              <a:lnSpc>
+                <a:spcPct val="100000"/>
+              </a:lnSpc>
+              <a:spcAft>
+                <a:spcPts val="600"/>
+              </a:spcAft>
+            </a:pPr>
+            <a:r>
+              <a:rPr sz="1500" b="0" i="0">
+                <a:solidFill>
+                  <a:srgbClr val="CADCFC"/>
+                </a:solidFill>
+                <a:latin typeface="Arial"/>
+              </a:rPr>
+              <a:t>one REFRESH: new lines, updated alerts, graded results, live ATS scorecard vs the 49.7% benchmark</a:t>
+            </a:r>
+          </a:p>
+        </p:txBody>
+      </p:sp>
+      <p:sp>
+        <p:nvSpPr>
+          <p:cNvPr id="10" name="TextBox 9"/>
+          <p:cNvSpPr txBox="1"/>
+          <p:nvPr/>
+        </p:nvSpPr>
+        <p:spPr>
+          <a:xfrm>
+            <a:off x="822960" y="4709159"/>
+            <a:ext cx="2377440" cy="548640"/>
+          </a:xfrm>
+          <a:prstGeom prst="rect">
+            <a:avLst/>
+          </a:prstGeom>
+          <a:noFill/>
+        </p:spPr>
+        <p:txBody>
+          <a:bodyPr wrap="square" anchor="t" lIns="0" rIns="0" tIns="0" bIns="0">
+            <a:spAutoFit/>
+          </a:bodyPr>
+          <a:lstStyle/>
+          <a:p>
+            <a:pPr algn="l">
+              <a:lnSpc>
+                <a:spcPct val="100000"/>
+              </a:lnSpc>
+              <a:spcAft>
+                <a:spcPts val="600"/>
+              </a:spcAft>
+            </a:pPr>
+            <a:r>
+              <a:rPr sz="1700" b="1" i="0">
+                <a:solidFill>
+                  <a:srgbClr val="F47321"/>
+                </a:solidFill>
+                <a:latin typeface="Arial"/>
+              </a:rPr>
+              <a:t>Beyond</a:t>
+            </a:r>
+          </a:p>
+        </p:txBody>
+      </p:sp>
+      <p:sp>
+        <p:nvSpPr>
+          <p:cNvPr id="11" name="TextBox 10"/>
+          <p:cNvSpPr txBox="1"/>
+          <p:nvPr/>
+        </p:nvSpPr>
+        <p:spPr>
+          <a:xfrm>
+            <a:off x="3383280" y="4709159"/>
+            <a:ext cx="7955279" cy="822960"/>
+          </a:xfrm>
+          <a:prstGeom prst="rect">
+            <a:avLst/>
+          </a:prstGeom>
+          <a:noFill/>
+        </p:spPr>
+        <p:txBody>
+          <a:bodyPr wrap="square" anchor="t" lIns="0" rIns="0" tIns="0" bIns="0">
+            <a:spAutoFit/>
+          </a:bodyPr>
+          <a:lstStyle/>
+          <a:p>
+            <a:pPr algn="l">
+              <a:lnSpc>
+                <a:spcPct val="100000"/>
+              </a:lnSpc>
+              <a:spcAft>
+                <a:spcPts val="600"/>
+              </a:spcAft>
+            </a:pPr>
+            <a:r>
+              <a:rPr sz="1500" b="0" i="0">
+                <a:solidFill>
+                  <a:srgbClr val="CADCFC"/>
+                </a:solidFill>
+                <a:latin typeface="Arial"/>
+              </a:rPr>
+              <a:t>coaching-change and QB flags, Vegas win totals as a feature, line-movement steam alerts</a:t>
+            </a:r>
+          </a:p>
+        </p:txBody>
+      </p:sp>
+      <p:sp>
+        <p:nvSpPr>
+          <p:cNvPr id="12" name="TextBox 11"/>
+          <p:cNvSpPr txBox="1"/>
+          <p:nvPr/>
+        </p:nvSpPr>
+        <p:spPr>
+          <a:xfrm>
+            <a:off x="822960" y="5943600"/>
+            <a:ext cx="10515600" cy="548640"/>
+          </a:xfrm>
+          <a:prstGeom prst="rect">
+            <a:avLst/>
+          </a:prstGeom>
+          <a:noFill/>
+        </p:spPr>
+        <p:txBody>
+          <a:bodyPr wrap="square" anchor="t" lIns="0" rIns="0" tIns="0" bIns="0">
+            <a:spAutoFit/>
+          </a:bodyPr>
+          <a:lstStyle/>
+          <a:p>
+            <a:pPr algn="l">
+              <a:lnSpc>
+                <a:spcPct val="100000"/>
+              </a:lnSpc>
+              <a:spcAft>
+                <a:spcPts val="600"/>
+              </a:spcAft>
+            </a:pPr>
+            <a:r>
+              <a:rPr sz="1200" b="0" i="0">
+                <a:solidFill>
+                  <a:srgbClr val="CADCFC"/>
+                </a:solidFill>
+                <a:latin typeface="Arial"/>
+              </a:rPr>
+              <a:t>Repo: Sports Data Analysis / ncaa-fbs-model  —  pipeline, tests, and README built for a hiring manager, not a journal.</a:t>
+            </a:r>
+          </a:p>
+        </p:txBody>
+      </p:sp>
+    </p:spTree>
+  </p:cSld>
+  <p:clrMapOvr>
+    <a:masterClrMapping/>
+  </p:clrMapOvr>
+</p:sld>
+</file>
+
 <file path=ppt/slides/slide2.xml><?xml version="1.0" encoding="utf-8"?>
 <p:sld xmlns:a="http://schemas.openxmlformats.org/drawingml/2006/main" xmlns:p="http://schemas.openxmlformats.org/presentationml/2006/main" xmlns:r="http://schemas.openxmlformats.org/officeDocument/2006/relationships">
   <p:cSld>
@@ -5162,7 +5645,7 @@
                 </a:solidFill>
                 <a:latin typeface="Arial"/>
               </a:rPr>
-              <a:t>CFBD mirrors final 2025 FPI, so this list doubles as a 2025 over/under-achievers list. A true preseason test needs a pre-week-1 snapshot — the pipeline captures one automatically when 2026 FPI publishes.</a:t>
+              <a:t>CFBD mirrors final 2025 FPI, so this list doubles as a 2025 over/under-achievers list. ESPN's 2026 preseason FPI was captured July 14 — the true preseason decomposition runs as soon as CFBD mirrors the 2026 inputs.</a:t>
             </a:r>
           </a:p>
         </p:txBody>
@@ -5904,7 +6387,7 @@
                 </a:solidFill>
                 <a:latin typeface="Arial"/>
               </a:rPr>
-              <a:t>pick any team from a dropdown → ratings, FPI, schedule, lines, roster</a:t>
+              <a:t>team dropdown → ratings, FPI, schedule + lines, roster, strengths/weaknesses, and an OurLads-sourced depth chart</a:t>
             </a:r>
           </a:p>
         </p:txBody>
@@ -5990,7 +6473,7 @@
                 </a:solidFill>
                 <a:latin typeface="Arial"/>
               </a:rPr>
-              <a:t>3 hidden data sheets</a:t>
+              <a:t>4 hidden data sheets</a:t>
             </a:r>
           </a:p>
         </p:txBody>
@@ -6032,7 +6515,7 @@
                 </a:solidFill>
                 <a:latin typeface="Arial"/>
               </a:rPr>
-              <a:t>_Teams / _Rosters / _Sched — 15,130 players, 1,776 schedule rows</a:t>
+              <a:t>_Teams / _Rosters / _Sched / _DepthGrid — 15,130 players, 1,776 schedule rows</a:t>
             </a:r>
           </a:p>
         </p:txBody>
@@ -7179,7 +7662,7 @@
                 </a:solidFill>
                 <a:latin typeface="Arial"/>
               </a:rPr>
-              <a:t>FPI-implied margin (FPI gap + 2.5 home field) vs the betting market</a:t>
+              <a:t>FPI-implied margin (FPI gap + 2.5 home field) vs the market — prior: ESPN's 2026 preseason FPI, captured July 14</a:t>
             </a:r>
           </a:p>
         </p:txBody>
@@ -7411,7 +7894,7 @@
                 </a:solidFill>
                 <a:latin typeface="Arial"/>
               </a:rPr>
-              <a:t>Live from the early week-1 lines (15 alerts, 4 red):</a:t>
+              <a:t>Live (5 alerts, 2 red) — with ESPN's real 2026 opinion, staleness noise vanished and what's left is signal:</a:t>
             </a:r>
           </a:p>
         </p:txBody>
@@ -7453,7 +7936,7 @@
                 </a:solidFill>
                 <a:latin typeface="Arial"/>
               </a:rPr>
-              <a:t>Oklahoma State -11.5 at Tulsa</a:t>
+              <a:t>Wisconsin -20.5 vs Notre Dame (N)</a:t>
             </a:r>
           </a:p>
         </p:txBody>
@@ -7495,7 +7978,7 @@
                 </a:solidFill>
                 <a:latin typeface="Arial"/>
               </a:rPr>
-              <a:t>FPI gap says pick'em — model takes Tulsa +11.5</a:t>
+              <a:t>41.6-pt edge = almost certainly a flipped line in the data feed — alerts catch data bugs too</a:t>
             </a:r>
           </a:p>
         </p:txBody>
@@ -7537,7 +8020,7 @@
                 </a:solidFill>
                 <a:latin typeface="Arial"/>
               </a:rPr>
-              <a:t>Toledo at Michigan State -10.5</a:t>
+              <a:t>Sacramento State at Eastern Michigan -8.5</a:t>
             </a:r>
           </a:p>
         </p:txBody>
@@ -7579,7 +8062,7 @@
                 </a:solidFill>
                 <a:latin typeface="Arial"/>
               </a:rPr>
-              <a:t>model actually favors Toledo on a neutral gap</a:t>
+              <a:t>ESPN's FPI likes the FBS newcomer outright — market hasn't priced them</a:t>
             </a:r>
           </a:p>
         </p:txBody>
@@ -7663,7 +8146,7 @@
                 </a:solidFill>
                 <a:latin typeface="Arial"/>
               </a:rPr>
-              <a:t>model says IU by 27 — the number is 13.5 too rich</a:t>
+              <a:t>even ESPN's 2026 numbers say the -40.5 is ~8 too rich</a:t>
             </a:r>
           </a:p>
         </p:txBody>
@@ -7705,7 +8188,7 @@
                 </a:solidFill>
                 <a:latin typeface="Arial"/>
               </a:rPr>
-              <a:t>Alabama -25.5 vs East Carolina</a:t>
+              <a:t>Massachusetts at Rutgers -30.5</a:t>
             </a:r>
           </a:p>
         </p:txBody>
@@ -7747,7 +8230,7 @@
                 </a:solidFill>
                 <a:latin typeface="Arial"/>
               </a:rPr>
-              <a:t>market rates Bama 9 points above the FPI prior</a:t>
+              <a:t>same shape: giant number, single-digit model disagreement</a:t>
             </a:r>
           </a:p>
         </p:txBody>
@@ -7858,7 +8341,7 @@
                 </a:solidFill>
                 <a:latin typeface="Arial"/>
               </a:rPr>
-              <a:t>Season Simulation</a:t>
+              <a:t>Backtested — and Honest About It</a:t>
             </a:r>
           </a:p>
         </p:txBody>
@@ -7900,29 +8383,55 @@
                 </a:solidFill>
                 <a:latin typeface="Arial"/>
               </a:rPr>
-              <a:t>10,000 Monte Carlo seasons per team — win prob = N(FPI gap + HFA, sd 13.5)</a:t>
-            </a:r>
-          </a:p>
-        </p:txBody>
-      </p:sp>
-      <p:graphicFrame>
-        <p:nvGraphicFramePr>
-          <p:cNvPr id="4" name="Chart 3"/>
-          <p:cNvGraphicFramePr>
-            <a:graphicFrameLocks noGrp="1"/>
-          </p:cNvGraphicFramePr>
-          <p:nvPr/>
-        </p:nvGraphicFramePr>
-        <p:xfrm>
-          <a:off x="548640" y="1645920"/>
-          <a:ext cx="6949440" cy="4480560"/>
-        </p:xfrm>
-        <a:graphic>
-          <a:graphicData uri="http://schemas.openxmlformats.org/drawingml/2006/chart">
-            <c:chart xmlns:c="http://schemas.openxmlformats.org/drawingml/2006/chart" r:id="rId2"/>
-          </a:graphicData>
-        </a:graphic>
-      </p:graphicFrame>
+              <a:t>The alert rules replayed against 2023–2025 with the exact information the live system would have had</a:t>
+            </a:r>
+          </a:p>
+        </p:txBody>
+      </p:sp>
+      <p:sp>
+        <p:nvSpPr>
+          <p:cNvPr id="4" name="Rectangle 3"/>
+          <p:cNvSpPr/>
+          <p:nvPr/>
+        </p:nvSpPr>
+        <p:spPr>
+          <a:xfrm>
+            <a:off x="548640" y="1645920"/>
+            <a:ext cx="3566160" cy="1737360"/>
+          </a:xfrm>
+          <a:prstGeom prst="rect">
+            <a:avLst/>
+          </a:prstGeom>
+          <a:solidFill>
+            <a:srgbClr val="F2F5FA"/>
+          </a:solidFill>
+          <a:ln>
+            <a:noFill/>
+          </a:ln>
+          <a:effectLst/>
+        </p:spPr>
+        <p:style>
+          <a:lnRef idx="1">
+            <a:schemeClr val="accent1"/>
+          </a:lnRef>
+          <a:fillRef idx="3">
+            <a:schemeClr val="accent1"/>
+          </a:fillRef>
+          <a:effectRef idx="2">
+            <a:schemeClr val="accent1"/>
+          </a:effectRef>
+          <a:fontRef idx="minor">
+            <a:schemeClr val="lt1"/>
+          </a:fontRef>
+        </p:style>
+        <p:txBody>
+          <a:bodyPr rtlCol="0" anchor="ctr"/>
+          <a:lstStyle/>
+          <a:p>
+            <a:pPr algn="ctr"/>
+          </a:p>
+        </p:txBody>
+      </p:sp>
       <p:sp>
         <p:nvSpPr>
           <p:cNvPr id="5" name="TextBox 4"/>
@@ -7931,8 +8440,8 @@
         </p:nvSpPr>
         <p:spPr>
           <a:xfrm>
-            <a:off x="7772400" y="1828800"/>
-            <a:ext cx="3840480" cy="4114800"/>
+            <a:off x="685800" y="1810512"/>
+            <a:ext cx="3291840" cy="914400"/>
           </a:xfrm>
           <a:prstGeom prst="rect">
             <a:avLst/>
@@ -7945,87 +8454,399 @@
           </a:bodyPr>
           <a:lstStyle/>
           <a:p>
-            <a:pPr algn="l">
-              <a:lnSpc>
-                <a:spcPct val="115000"/>
-              </a:lnSpc>
-              <a:spcAft>
-                <a:spcPts val="1400"/>
-              </a:spcAft>
-            </a:pPr>
-            <a:r>
-              <a:rPr sz="1400" b="1" i="0">
+            <a:pPr algn="ctr">
+              <a:lnSpc>
+                <a:spcPct val="100000"/>
+              </a:lnSpc>
+              <a:spcAft>
+                <a:spcPts val="600"/>
+              </a:spcAft>
+            </a:pPr>
+            <a:r>
+              <a:rPr sz="4400" b="1" i="0">
                 <a:solidFill>
                   <a:srgbClr val="0A2851"/>
                 </a:solidFill>
                 <a:latin typeface="Arial"/>
               </a:rPr>
-              <a:t>Per team: </a:t>
-            </a:r>
-            <a:r>
-              <a:rPr sz="1400" b="0" i="0">
+              <a:t>1,147</a:t>
+            </a:r>
+          </a:p>
+        </p:txBody>
+      </p:sp>
+      <p:sp>
+        <p:nvSpPr>
+          <p:cNvPr id="6" name="TextBox 5"/>
+          <p:cNvSpPr txBox="1"/>
+          <p:nvPr/>
+        </p:nvSpPr>
+        <p:spPr>
+          <a:xfrm>
+            <a:off x="685800" y="2697480"/>
+            <a:ext cx="3291840" cy="594360"/>
+          </a:xfrm>
+          <a:prstGeom prst="rect">
+            <a:avLst/>
+          </a:prstGeom>
+          <a:noFill/>
+        </p:spPr>
+        <p:txBody>
+          <a:bodyPr wrap="square" anchor="t" lIns="0" rIns="0" tIns="0" bIns="0">
+            <a:spAutoFit/>
+          </a:bodyPr>
+          <a:lstStyle/>
+          <a:p>
+            <a:pPr algn="ctr">
+              <a:lnSpc>
+                <a:spcPct val="100000"/>
+              </a:lnSpc>
+              <a:spcAft>
+                <a:spcPts val="600"/>
+              </a:spcAft>
+            </a:pPr>
+            <a:r>
+              <a:rPr sz="1200" b="0" i="0">
+                <a:solidFill>
+                  <a:srgbClr val="666666"/>
+                </a:solidFill>
+                <a:latin typeface="Arial"/>
+              </a:rPr>
+              <a:t>alerts replayed across three seasons of real closing lines</a:t>
+            </a:r>
+          </a:p>
+        </p:txBody>
+      </p:sp>
+      <p:sp>
+        <p:nvSpPr>
+          <p:cNvPr id="7" name="Rectangle 6"/>
+          <p:cNvSpPr/>
+          <p:nvPr/>
+        </p:nvSpPr>
+        <p:spPr>
+          <a:xfrm>
+            <a:off x="4343400" y="1645920"/>
+            <a:ext cx="3566160" cy="1737360"/>
+          </a:xfrm>
+          <a:prstGeom prst="rect">
+            <a:avLst/>
+          </a:prstGeom>
+          <a:solidFill>
+            <a:srgbClr val="F2F5FA"/>
+          </a:solidFill>
+          <a:ln>
+            <a:noFill/>
+          </a:ln>
+          <a:effectLst/>
+        </p:spPr>
+        <p:style>
+          <a:lnRef idx="1">
+            <a:schemeClr val="accent1"/>
+          </a:lnRef>
+          <a:fillRef idx="3">
+            <a:schemeClr val="accent1"/>
+          </a:fillRef>
+          <a:effectRef idx="2">
+            <a:schemeClr val="accent1"/>
+          </a:effectRef>
+          <a:fontRef idx="minor">
+            <a:schemeClr val="lt1"/>
+          </a:fontRef>
+        </p:style>
+        <p:txBody>
+          <a:bodyPr rtlCol="0" anchor="ctr"/>
+          <a:lstStyle/>
+          <a:p>
+            <a:pPr algn="ctr"/>
+          </a:p>
+        </p:txBody>
+      </p:sp>
+      <p:sp>
+        <p:nvSpPr>
+          <p:cNvPr id="8" name="TextBox 7"/>
+          <p:cNvSpPr txBox="1"/>
+          <p:nvPr/>
+        </p:nvSpPr>
+        <p:spPr>
+          <a:xfrm>
+            <a:off x="4480560" y="1810512"/>
+            <a:ext cx="3291840" cy="914400"/>
+          </a:xfrm>
+          <a:prstGeom prst="rect">
+            <a:avLst/>
+          </a:prstGeom>
+          <a:noFill/>
+        </p:spPr>
+        <p:txBody>
+          <a:bodyPr wrap="square" anchor="t" lIns="0" rIns="0" tIns="0" bIns="0">
+            <a:spAutoFit/>
+          </a:bodyPr>
+          <a:lstStyle/>
+          <a:p>
+            <a:pPr algn="ctr">
+              <a:lnSpc>
+                <a:spcPct val="100000"/>
+              </a:lnSpc>
+              <a:spcAft>
+                <a:spcPts val="600"/>
+              </a:spcAft>
+            </a:pPr>
+            <a:r>
+              <a:rPr sz="4400" b="1" i="0">
+                <a:solidFill>
+                  <a:srgbClr val="9C0006"/>
+                </a:solidFill>
+                <a:latin typeface="Arial"/>
+              </a:rPr>
+              <a:t>49.7%</a:t>
+            </a:r>
+          </a:p>
+        </p:txBody>
+      </p:sp>
+      <p:sp>
+        <p:nvSpPr>
+          <p:cNvPr id="9" name="TextBox 8"/>
+          <p:cNvSpPr txBox="1"/>
+          <p:nvPr/>
+        </p:nvSpPr>
+        <p:spPr>
+          <a:xfrm>
+            <a:off x="4480560" y="2697480"/>
+            <a:ext cx="3291840" cy="594360"/>
+          </a:xfrm>
+          <a:prstGeom prst="rect">
+            <a:avLst/>
+          </a:prstGeom>
+          <a:noFill/>
+        </p:spPr>
+        <p:txBody>
+          <a:bodyPr wrap="square" anchor="t" lIns="0" rIns="0" tIns="0" bIns="0">
+            <a:spAutoFit/>
+          </a:bodyPr>
+          <a:lstStyle/>
+          <a:p>
+            <a:pPr algn="ctr">
+              <a:lnSpc>
+                <a:spcPct val="100000"/>
+              </a:lnSpc>
+              <a:spcAft>
+                <a:spcPts val="600"/>
+              </a:spcAft>
+            </a:pPr>
+            <a:r>
+              <a:rPr sz="1200" b="0" i="0">
+                <a:solidFill>
+                  <a:srgbClr val="666666"/>
+                </a:solidFill>
+                <a:latin typeface="Arial"/>
+              </a:rPr>
+              <a:t>ATS — below the 52.4% break-even. The stale-prior signal does NOT beat the market</a:t>
+            </a:r>
+          </a:p>
+        </p:txBody>
+      </p:sp>
+      <p:sp>
+        <p:nvSpPr>
+          <p:cNvPr id="10" name="Rectangle 9"/>
+          <p:cNvSpPr/>
+          <p:nvPr/>
+        </p:nvSpPr>
+        <p:spPr>
+          <a:xfrm>
+            <a:off x="8138160" y="1645920"/>
+            <a:ext cx="3566160" cy="1737360"/>
+          </a:xfrm>
+          <a:prstGeom prst="rect">
+            <a:avLst/>
+          </a:prstGeom>
+          <a:solidFill>
+            <a:srgbClr val="F2F5FA"/>
+          </a:solidFill>
+          <a:ln>
+            <a:noFill/>
+          </a:ln>
+          <a:effectLst/>
+        </p:spPr>
+        <p:style>
+          <a:lnRef idx="1">
+            <a:schemeClr val="accent1"/>
+          </a:lnRef>
+          <a:fillRef idx="3">
+            <a:schemeClr val="accent1"/>
+          </a:fillRef>
+          <a:effectRef idx="2">
+            <a:schemeClr val="accent1"/>
+          </a:effectRef>
+          <a:fontRef idx="minor">
+            <a:schemeClr val="lt1"/>
+          </a:fontRef>
+        </p:style>
+        <p:txBody>
+          <a:bodyPr rtlCol="0" anchor="ctr"/>
+          <a:lstStyle/>
+          <a:p>
+            <a:pPr algn="ctr"/>
+          </a:p>
+        </p:txBody>
+      </p:sp>
+      <p:sp>
+        <p:nvSpPr>
+          <p:cNvPr id="11" name="TextBox 10"/>
+          <p:cNvSpPr txBox="1"/>
+          <p:nvPr/>
+        </p:nvSpPr>
+        <p:spPr>
+          <a:xfrm>
+            <a:off x="8275320" y="1810512"/>
+            <a:ext cx="3291840" cy="914400"/>
+          </a:xfrm>
+          <a:prstGeom prst="rect">
+            <a:avLst/>
+          </a:prstGeom>
+          <a:noFill/>
+        </p:spPr>
+        <p:txBody>
+          <a:bodyPr wrap="square" anchor="t" lIns="0" rIns="0" tIns="0" bIns="0">
+            <a:spAutoFit/>
+          </a:bodyPr>
+          <a:lstStyle/>
+          <a:p>
+            <a:pPr algn="ctr">
+              <a:lnSpc>
+                <a:spcPct val="100000"/>
+              </a:lnSpc>
+              <a:spcAft>
+                <a:spcPts val="600"/>
+              </a:spcAft>
+            </a:pPr>
+            <a:r>
+              <a:rPr sz="4400" b="1" i="0">
+                <a:solidFill>
+                  <a:srgbClr val="9C0006"/>
+                </a:solidFill>
+                <a:latin typeface="Arial"/>
+              </a:rPr>
+              <a:t>46.8%</a:t>
+            </a:r>
+          </a:p>
+        </p:txBody>
+      </p:sp>
+      <p:sp>
+        <p:nvSpPr>
+          <p:cNvPr id="12" name="TextBox 11"/>
+          <p:cNvSpPr txBox="1"/>
+          <p:nvPr/>
+        </p:nvSpPr>
+        <p:spPr>
+          <a:xfrm>
+            <a:off x="8275320" y="2697480"/>
+            <a:ext cx="3291840" cy="594360"/>
+          </a:xfrm>
+          <a:prstGeom prst="rect">
+            <a:avLst/>
+          </a:prstGeom>
+          <a:noFill/>
+        </p:spPr>
+        <p:txBody>
+          <a:bodyPr wrap="square" anchor="t" lIns="0" rIns="0" tIns="0" bIns="0">
+            <a:spAutoFit/>
+          </a:bodyPr>
+          <a:lstStyle/>
+          <a:p>
+            <a:pPr algn="ctr">
+              <a:lnSpc>
+                <a:spcPct val="100000"/>
+              </a:lnSpc>
+              <a:spcAft>
+                <a:spcPts val="600"/>
+              </a:spcAft>
+            </a:pPr>
+            <a:r>
+              <a:rPr sz="1200" b="0" i="0">
+                <a:solidFill>
+                  <a:srgbClr val="666666"/>
+                </a:solidFill>
+                <a:latin typeface="Arial"/>
+              </a:rPr>
+              <a:t>on the LARGEST edges (15+ pts) — loud disagreement with the market is model error, not market error</a:t>
+            </a:r>
+          </a:p>
+        </p:txBody>
+      </p:sp>
+      <p:sp>
+        <p:nvSpPr>
+          <p:cNvPr id="13" name="TextBox 12"/>
+          <p:cNvSpPr txBox="1"/>
+          <p:nvPr/>
+        </p:nvSpPr>
+        <p:spPr>
+          <a:xfrm>
+            <a:off x="548640" y="3840480"/>
+            <a:ext cx="11155680" cy="2377440"/>
+          </a:xfrm>
+          <a:prstGeom prst="rect">
+            <a:avLst/>
+          </a:prstGeom>
+          <a:noFill/>
+        </p:spPr>
+        <p:txBody>
+          <a:bodyPr wrap="square" anchor="t" lIns="0" rIns="0" tIns="0" bIns="0">
+            <a:spAutoFit/>
+          </a:bodyPr>
+          <a:lstStyle/>
+          <a:p>
+            <a:pPr algn="l">
+              <a:lnSpc>
+                <a:spcPct val="120000"/>
+              </a:lnSpc>
+              <a:spcAft>
+                <a:spcPts val="1200"/>
+              </a:spcAft>
+            </a:pPr>
+            <a:r>
+              <a:rPr sz="1500" b="1" i="0">
+                <a:solidFill>
+                  <a:srgbClr val="0A2851"/>
+                </a:solidFill>
+                <a:latin typeface="Arial"/>
+              </a:rPr>
+              <a:t>Why report a losing record? </a:t>
+            </a:r>
+            <a:r>
+              <a:rPr sz="1500" b="0" i="0">
                 <a:solidFill>
                   <a:srgbClr val="222222"/>
                 </a:solidFill>
                 <a:latin typeface="Arial"/>
               </a:rPr>
-              <a:t>projected wins, 10th/90th percentile seasons, P(bowl), P(10+ wins).</a:t>
-            </a:r>
-          </a:p>
-          <a:p>
-            <a:pPr algn="l">
-              <a:lnSpc>
-                <a:spcPct val="115000"/>
-              </a:lnSpc>
-              <a:spcAft>
-                <a:spcPts val="1400"/>
-              </a:spcAft>
-            </a:pPr>
-            <a:r>
-              <a:rPr sz="1400" b="1" i="0">
+              <a:t>Because it's true, it's measured properly (graded against first-seen lines, no retroactive flattering), and it's exactly the analysis a sportsbook pays for: knowing which signals DON'T carry edge.</a:t>
+            </a:r>
+          </a:p>
+          <a:p>
+            <a:pPr algn="l">
+              <a:lnSpc>
+                <a:spcPct val="120000"/>
+              </a:lnSpc>
+              <a:spcAft>
+                <a:spcPts val="1200"/>
+              </a:spcAft>
+            </a:pPr>
+            <a:r>
+              <a:rPr sz="1500" b="1" i="0">
                 <a:solidFill>
                   <a:srgbClr val="0A2851"/>
                 </a:solidFill>
                 <a:latin typeface="Arial"/>
               </a:rPr>
-              <a:t>The play: </a:t>
-            </a:r>
-            <a:r>
-              <a:rPr sz="1400" b="0" i="0">
+              <a:t>What it changed: </a:t>
+            </a:r>
+            <a:r>
+              <a:rPr sz="1500" b="0" i="0">
                 <a:solidFill>
                   <a:srgbClr val="222222"/>
                 </a:solidFill>
                 <a:latin typeface="Arial"/>
               </a:rPr>
-              <a:t>compare projections to season win totals at the book. Gaps of a full win are the shortlist.</a:t>
-            </a:r>
-          </a:p>
-          <a:p>
-            <a:pPr algn="l">
-              <a:lnSpc>
-                <a:spcPct val="115000"/>
-              </a:lnSpc>
-              <a:spcAft>
-                <a:spcPts val="1400"/>
-              </a:spcAft>
-            </a:pPr>
-            <a:r>
-              <a:rPr sz="1400" b="1" i="0">
-                <a:solidFill>
-                  <a:srgbClr val="0A2851"/>
-                </a:solidFill>
-                <a:latin typeface="Arial"/>
-              </a:rPr>
-              <a:t>Prior upgrades itself: </a:t>
-            </a:r>
-            <a:r>
-              <a:rPr sz="1400" b="0" i="0">
-                <a:solidFill>
-                  <a:srgbClr val="222222"/>
-                </a:solidFill>
-                <a:latin typeface="Arial"/>
-              </a:rPr>
-              <a:t>when ESPN drops 2026 preseason FPI, the next refresh snapshots it and every projection sharpens.</a:t>
+              <a:t>the live board now runs on ESPN's actual 2026 preseason FPI instead of a stale prior — alerts fell from 15 to 5 overnight — and the board is framed as a research shortlist and narrative engine, not a picks service. Every future alert is logged and graded, so the 2026 record accumulates in public.</a:t>
             </a:r>
           </a:p>
         </p:txBody>
@@ -8050,58 +8871,14 @@
       <p:grpSpPr/>
       <p:sp>
         <p:nvSpPr>
-          <p:cNvPr id="2" name="Rectangle 1"/>
-          <p:cNvSpPr/>
-          <p:nvPr/>
-        </p:nvSpPr>
-        <p:spPr>
-          <a:xfrm>
-            <a:off x="0" y="0"/>
-            <a:ext cx="12191695" cy="6858000"/>
-          </a:xfrm>
-          <a:prstGeom prst="rect">
-            <a:avLst/>
-          </a:prstGeom>
-          <a:solidFill>
-            <a:srgbClr val="0A2851"/>
-          </a:solidFill>
-          <a:ln>
-            <a:noFill/>
-          </a:ln>
-          <a:effectLst/>
-        </p:spPr>
-        <p:style>
-          <a:lnRef idx="1">
-            <a:schemeClr val="accent1"/>
-          </a:lnRef>
-          <a:fillRef idx="3">
-            <a:schemeClr val="accent1"/>
-          </a:fillRef>
-          <a:effectRef idx="2">
-            <a:schemeClr val="accent1"/>
-          </a:effectRef>
-          <a:fontRef idx="minor">
-            <a:schemeClr val="lt1"/>
-          </a:fontRef>
-        </p:style>
-        <p:txBody>
-          <a:bodyPr rtlCol="0" anchor="ctr"/>
-          <a:lstStyle/>
-          <a:p>
-            <a:pPr algn="ctr"/>
-          </a:p>
-        </p:txBody>
-      </p:sp>
-      <p:sp>
-        <p:nvSpPr>
-          <p:cNvPr id="3" name="TextBox 2"/>
+          <p:cNvPr id="2" name="TextBox 1"/>
           <p:cNvSpPr txBox="1"/>
           <p:nvPr/>
         </p:nvSpPr>
         <p:spPr>
           <a:xfrm>
-            <a:off x="822960" y="640080"/>
-            <a:ext cx="10515600" cy="822960"/>
+            <a:off x="548640" y="320040"/>
+            <a:ext cx="11064240" cy="822960"/>
           </a:xfrm>
           <a:prstGeom prst="rect">
             <a:avLst/>
@@ -8123,27 +8900,27 @@
               </a:spcAft>
             </a:pPr>
             <a:r>
-              <a:rPr sz="3600" b="1" i="0">
-                <a:solidFill>
-                  <a:srgbClr val="FFFFFF"/>
-                </a:solidFill>
-                <a:latin typeface="Arial"/>
-              </a:rPr>
-              <a:t>What's Next</a:t>
-            </a:r>
-          </a:p>
-        </p:txBody>
-      </p:sp>
-      <p:sp>
-        <p:nvSpPr>
-          <p:cNvPr id="4" name="TextBox 3"/>
+              <a:rPr sz="3400" b="1" i="0">
+                <a:solidFill>
+                  <a:srgbClr val="0A2851"/>
+                </a:solidFill>
+                <a:latin typeface="Arial"/>
+              </a:rPr>
+              <a:t>Season Simulation</a:t>
+            </a:r>
+          </a:p>
+        </p:txBody>
+      </p:sp>
+      <p:sp>
+        <p:nvSpPr>
+          <p:cNvPr id="3" name="TextBox 2"/>
           <p:cNvSpPr txBox="1"/>
           <p:nvPr/>
         </p:nvSpPr>
         <p:spPr>
           <a:xfrm>
-            <a:off x="822960" y="1828800"/>
-            <a:ext cx="2377440" cy="548640"/>
+            <a:off x="548640" y="1024128"/>
+            <a:ext cx="11064240" cy="457200"/>
           </a:xfrm>
           <a:prstGeom prst="rect">
             <a:avLst/>
@@ -8165,17 +8942,35 @@
               </a:spcAft>
             </a:pPr>
             <a:r>
-              <a:rPr sz="1700" b="1" i="0">
-                <a:solidFill>
-                  <a:srgbClr val="F47321"/>
-                </a:solidFill>
-                <a:latin typeface="Arial"/>
-              </a:rPr>
-              <a:t>August</a:t>
-            </a:r>
-          </a:p>
-        </p:txBody>
-      </p:sp>
+              <a:rPr sz="1400" b="0" i="0">
+                <a:solidFill>
+                  <a:srgbClr val="666666"/>
+                </a:solidFill>
+                <a:latin typeface="Arial"/>
+              </a:rPr>
+              <a:t>10,000 Monte Carlo seasons per team — prior: ESPN 2026 preseason FPI — win prob = N(FPI gap + HFA, sd 13.5)</a:t>
+            </a:r>
+          </a:p>
+        </p:txBody>
+      </p:sp>
+      <p:graphicFrame>
+        <p:nvGraphicFramePr>
+          <p:cNvPr id="4" name="Chart 3"/>
+          <p:cNvGraphicFramePr>
+            <a:graphicFrameLocks noGrp="1"/>
+          </p:cNvGraphicFramePr>
+          <p:nvPr/>
+        </p:nvGraphicFramePr>
+        <p:xfrm>
+          <a:off x="548640" y="1645920"/>
+          <a:ext cx="6949440" cy="4480560"/>
+        </p:xfrm>
+        <a:graphic>
+          <a:graphicData uri="http://schemas.openxmlformats.org/drawingml/2006/chart">
+            <c:chart xmlns:c="http://schemas.openxmlformats.org/drawingml/2006/chart" r:id="rId2"/>
+          </a:graphicData>
+        </a:graphic>
+      </p:graphicFrame>
       <p:sp>
         <p:nvSpPr>
           <p:cNvPr id="5" name="TextBox 4"/>
@@ -8184,8 +8979,8 @@
         </p:nvSpPr>
         <p:spPr>
           <a:xfrm>
-            <a:off x="3383280" y="1828800"/>
-            <a:ext cx="7955279" cy="822960"/>
+            <a:off x="7772400" y="1828800"/>
+            <a:ext cx="3840480" cy="4114800"/>
           </a:xfrm>
           <a:prstGeom prst="rect">
             <a:avLst/>
@@ -8200,314 +8995,85 @@
           <a:p>
             <a:pPr algn="l">
               <a:lnSpc>
-                <a:spcPct val="100000"/>
-              </a:lnSpc>
-              <a:spcAft>
-                <a:spcPts val="600"/>
-              </a:spcAft>
-            </a:pPr>
-            <a:r>
-              <a:rPr sz="1500" b="0" i="0">
-                <a:solidFill>
-                  <a:srgbClr val="CADCFC"/>
-                </a:solidFill>
-                <a:latin typeface="Arial"/>
-              </a:rPr>
-              <a:t>2026 preseason FPI snapshot lands automatically — true preseason decomposition, sharper alerts</a:t>
-            </a:r>
-          </a:p>
-        </p:txBody>
-      </p:sp>
-      <p:sp>
-        <p:nvSpPr>
-          <p:cNvPr id="6" name="TextBox 5"/>
-          <p:cNvSpPr txBox="1"/>
-          <p:nvPr/>
-        </p:nvSpPr>
-        <p:spPr>
-          <a:xfrm>
-            <a:off x="822960" y="2788920"/>
-            <a:ext cx="2377440" cy="548640"/>
-          </a:xfrm>
-          <a:prstGeom prst="rect">
-            <a:avLst/>
-          </a:prstGeom>
-          <a:noFill/>
-        </p:spPr>
-        <p:txBody>
-          <a:bodyPr wrap="square" anchor="t" lIns="0" rIns="0" tIns="0" bIns="0">
-            <a:spAutoFit/>
-          </a:bodyPr>
-          <a:lstStyle/>
-          <a:p>
-            <a:pPr algn="l">
-              <a:lnSpc>
-                <a:spcPct val="100000"/>
-              </a:lnSpc>
-              <a:spcAft>
-                <a:spcPts val="600"/>
-              </a:spcAft>
-            </a:pPr>
-            <a:r>
-              <a:rPr sz="1700" b="1" i="0">
-                <a:solidFill>
-                  <a:srgbClr val="F47321"/>
-                </a:solidFill>
-                <a:latin typeface="Arial"/>
-              </a:rPr>
-              <a:t>Weekly in-season</a:t>
-            </a:r>
-          </a:p>
-        </p:txBody>
-      </p:sp>
-      <p:sp>
-        <p:nvSpPr>
-          <p:cNvPr id="7" name="TextBox 6"/>
-          <p:cNvSpPr txBox="1"/>
-          <p:nvPr/>
-        </p:nvSpPr>
-        <p:spPr>
-          <a:xfrm>
-            <a:off x="3383280" y="2788920"/>
-            <a:ext cx="7955279" cy="822960"/>
-          </a:xfrm>
-          <a:prstGeom prst="rect">
-            <a:avLst/>
-          </a:prstGeom>
-          <a:noFill/>
-        </p:spPr>
-        <p:txBody>
-          <a:bodyPr wrap="square" anchor="t" lIns="0" rIns="0" tIns="0" bIns="0">
-            <a:spAutoFit/>
-          </a:bodyPr>
-          <a:lstStyle/>
-          <a:p>
-            <a:pPr algn="l">
-              <a:lnSpc>
-                <a:spcPct val="100000"/>
-              </a:lnSpc>
-              <a:spcAft>
-                <a:spcPts val="600"/>
-              </a:spcAft>
-            </a:pPr>
-            <a:r>
-              <a:rPr sz="1500" b="0" i="0">
-                <a:solidFill>
-                  <a:srgbClr val="CADCFC"/>
-                </a:solidFill>
-                <a:latin typeface="Arial"/>
-              </a:rPr>
-              <a:t>one REFRESH: new lines, updated alerts, graded results, live ATS scorecard</a:t>
-            </a:r>
-          </a:p>
-        </p:txBody>
-      </p:sp>
-      <p:sp>
-        <p:nvSpPr>
-          <p:cNvPr id="8" name="TextBox 7"/>
-          <p:cNvSpPr txBox="1"/>
-          <p:nvPr/>
-        </p:nvSpPr>
-        <p:spPr>
-          <a:xfrm>
-            <a:off x="822960" y="3749039"/>
-            <a:ext cx="2377440" cy="548640"/>
-          </a:xfrm>
-          <a:prstGeom prst="rect">
-            <a:avLst/>
-          </a:prstGeom>
-          <a:noFill/>
-        </p:spPr>
-        <p:txBody>
-          <a:bodyPr wrap="square" anchor="t" lIns="0" rIns="0" tIns="0" bIns="0">
-            <a:spAutoFit/>
-          </a:bodyPr>
-          <a:lstStyle/>
-          <a:p>
-            <a:pPr algn="l">
-              <a:lnSpc>
-                <a:spcPct val="100000"/>
-              </a:lnSpc>
-              <a:spcAft>
-                <a:spcPts val="600"/>
-              </a:spcAft>
-            </a:pPr>
-            <a:r>
-              <a:rPr sz="1700" b="1" i="0">
-                <a:solidFill>
-                  <a:srgbClr val="F47321"/>
-                </a:solidFill>
-                <a:latin typeface="Arial"/>
-              </a:rPr>
-              <a:t>October</a:t>
-            </a:r>
-          </a:p>
-        </p:txBody>
-      </p:sp>
-      <p:sp>
-        <p:nvSpPr>
-          <p:cNvPr id="9" name="TextBox 8"/>
-          <p:cNvSpPr txBox="1"/>
-          <p:nvPr/>
-        </p:nvSpPr>
-        <p:spPr>
-          <a:xfrm>
-            <a:off x="3383280" y="3749039"/>
-            <a:ext cx="7955279" cy="822960"/>
-          </a:xfrm>
-          <a:prstGeom prst="rect">
-            <a:avLst/>
-          </a:prstGeom>
-          <a:noFill/>
-        </p:spPr>
-        <p:txBody>
-          <a:bodyPr wrap="square" anchor="t" lIns="0" rIns="0" tIns="0" bIns="0">
-            <a:spAutoFit/>
-          </a:bodyPr>
-          <a:lstStyle/>
-          <a:p>
-            <a:pPr algn="l">
-              <a:lnSpc>
-                <a:spcPct val="100000"/>
-              </a:lnSpc>
-              <a:spcAft>
-                <a:spcPts val="600"/>
-              </a:spcAft>
-            </a:pPr>
-            <a:r>
-              <a:rPr sz="1500" b="0" i="0">
-                <a:solidFill>
-                  <a:srgbClr val="CADCFC"/>
-                </a:solidFill>
-                <a:latin typeface="Arial"/>
-              </a:rPr>
-              <a:t>the model's record speaks — 'the alert went X–Y ATS' beats any backtest slide</a:t>
-            </a:r>
-          </a:p>
-        </p:txBody>
-      </p:sp>
-      <p:sp>
-        <p:nvSpPr>
-          <p:cNvPr id="10" name="TextBox 9"/>
-          <p:cNvSpPr txBox="1"/>
-          <p:nvPr/>
-        </p:nvSpPr>
-        <p:spPr>
-          <a:xfrm>
-            <a:off x="822960" y="4709159"/>
-            <a:ext cx="2377440" cy="548640"/>
-          </a:xfrm>
-          <a:prstGeom prst="rect">
-            <a:avLst/>
-          </a:prstGeom>
-          <a:noFill/>
-        </p:spPr>
-        <p:txBody>
-          <a:bodyPr wrap="square" anchor="t" lIns="0" rIns="0" tIns="0" bIns="0">
-            <a:spAutoFit/>
-          </a:bodyPr>
-          <a:lstStyle/>
-          <a:p>
-            <a:pPr algn="l">
-              <a:lnSpc>
-                <a:spcPct val="100000"/>
-              </a:lnSpc>
-              <a:spcAft>
-                <a:spcPts val="600"/>
-              </a:spcAft>
-            </a:pPr>
-            <a:r>
-              <a:rPr sz="1700" b="1" i="0">
-                <a:solidFill>
-                  <a:srgbClr val="F47321"/>
-                </a:solidFill>
-                <a:latin typeface="Arial"/>
-              </a:rPr>
-              <a:t>Beyond</a:t>
-            </a:r>
-          </a:p>
-        </p:txBody>
-      </p:sp>
-      <p:sp>
-        <p:nvSpPr>
-          <p:cNvPr id="11" name="TextBox 10"/>
-          <p:cNvSpPr txBox="1"/>
-          <p:nvPr/>
-        </p:nvSpPr>
-        <p:spPr>
-          <a:xfrm>
-            <a:off x="3383280" y="4709159"/>
-            <a:ext cx="7955279" cy="822960"/>
-          </a:xfrm>
-          <a:prstGeom prst="rect">
-            <a:avLst/>
-          </a:prstGeom>
-          <a:noFill/>
-        </p:spPr>
-        <p:txBody>
-          <a:bodyPr wrap="square" anchor="t" lIns="0" rIns="0" tIns="0" bIns="0">
-            <a:spAutoFit/>
-          </a:bodyPr>
-          <a:lstStyle/>
-          <a:p>
-            <a:pPr algn="l">
-              <a:lnSpc>
-                <a:spcPct val="100000"/>
-              </a:lnSpc>
-              <a:spcAft>
-                <a:spcPts val="600"/>
-              </a:spcAft>
-            </a:pPr>
-            <a:r>
-              <a:rPr sz="1500" b="0" i="0">
-                <a:solidFill>
-                  <a:srgbClr val="CADCFC"/>
-                </a:solidFill>
-                <a:latin typeface="Arial"/>
-              </a:rPr>
-              <a:t>coaching-change and QB flags, Vegas win totals as a feature, line-movement steam alerts</a:t>
-            </a:r>
-          </a:p>
-        </p:txBody>
-      </p:sp>
-      <p:sp>
-        <p:nvSpPr>
-          <p:cNvPr id="12" name="TextBox 11"/>
-          <p:cNvSpPr txBox="1"/>
-          <p:nvPr/>
-        </p:nvSpPr>
-        <p:spPr>
-          <a:xfrm>
-            <a:off x="822960" y="5943600"/>
-            <a:ext cx="10515600" cy="548640"/>
-          </a:xfrm>
-          <a:prstGeom prst="rect">
-            <a:avLst/>
-          </a:prstGeom>
-          <a:noFill/>
-        </p:spPr>
-        <p:txBody>
-          <a:bodyPr wrap="square" anchor="t" lIns="0" rIns="0" tIns="0" bIns="0">
-            <a:spAutoFit/>
-          </a:bodyPr>
-          <a:lstStyle/>
-          <a:p>
-            <a:pPr algn="l">
-              <a:lnSpc>
-                <a:spcPct val="100000"/>
-              </a:lnSpc>
-              <a:spcAft>
-                <a:spcPts val="600"/>
-              </a:spcAft>
-            </a:pPr>
-            <a:r>
-              <a:rPr sz="1200" b="0" i="0">
-                <a:solidFill>
-                  <a:srgbClr val="CADCFC"/>
-                </a:solidFill>
-                <a:latin typeface="Arial"/>
-              </a:rPr>
-              <a:t>Repo: Sports Data Analysis / ncaa-fbs-model  —  pipeline, tests, and README built for a hiring manager, not a journal.</a:t>
+                <a:spcPct val="115000"/>
+              </a:lnSpc>
+              <a:spcAft>
+                <a:spcPts val="1400"/>
+              </a:spcAft>
+            </a:pPr>
+            <a:r>
+              <a:rPr sz="1400" b="1" i="0">
+                <a:solidFill>
+                  <a:srgbClr val="0A2851"/>
+                </a:solidFill>
+                <a:latin typeface="Arial"/>
+              </a:rPr>
+              <a:t>Per team: </a:t>
+            </a:r>
+            <a:r>
+              <a:rPr sz="1400" b="0" i="0">
+                <a:solidFill>
+                  <a:srgbClr val="222222"/>
+                </a:solidFill>
+                <a:latin typeface="Arial"/>
+              </a:rPr>
+              <a:t>projected wins, 10th/90th percentile seasons, P(bowl), P(10+ wins).</a:t>
+            </a:r>
+          </a:p>
+          <a:p>
+            <a:pPr algn="l">
+              <a:lnSpc>
+                <a:spcPct val="115000"/>
+              </a:lnSpc>
+              <a:spcAft>
+                <a:spcPts val="1400"/>
+              </a:spcAft>
+            </a:pPr>
+            <a:r>
+              <a:rPr sz="1400" b="1" i="0">
+                <a:solidFill>
+                  <a:srgbClr val="0A2851"/>
+                </a:solidFill>
+                <a:latin typeface="Arial"/>
+              </a:rPr>
+              <a:t>The play: </a:t>
+            </a:r>
+            <a:r>
+              <a:rPr sz="1400" b="0" i="0">
+                <a:solidFill>
+                  <a:srgbClr val="222222"/>
+                </a:solidFill>
+                <a:latin typeface="Arial"/>
+              </a:rPr>
+              <a:t>compare projections to season win totals at the book. Gaps of a full win are the shortlist.</a:t>
+            </a:r>
+          </a:p>
+          <a:p>
+            <a:pPr algn="l">
+              <a:lnSpc>
+                <a:spcPct val="115000"/>
+              </a:lnSpc>
+              <a:spcAft>
+                <a:spcPts val="1400"/>
+              </a:spcAft>
+            </a:pPr>
+            <a:r>
+              <a:rPr sz="1400" b="1" i="0">
+                <a:solidFill>
+                  <a:srgbClr val="0A2851"/>
+                </a:solidFill>
+                <a:latin typeface="Arial"/>
+              </a:rPr>
+              <a:t>Prior already upgraded: </a:t>
+            </a:r>
+            <a:r>
+              <a:rPr sz="1400" b="0" i="0">
+                <a:solidFill>
+                  <a:srgbClr val="222222"/>
+                </a:solidFill>
+                <a:latin typeface="Arial"/>
+              </a:rPr>
+              <a:t>ESPN's 2026 preseason FPI (released July 2026) now drives every projection — all 138 teams are simulated, newcomers included.</a:t>
             </a:r>
           </a:p>
         </p:txBody>

</xml_diff>

<commit_message>
Quality-weighted portal feature: the null result becomes a finding
net_portal_q: value above 0.75 replacement, 247-style Gaussian
diminishing returns, star-grade imputation for unrated transfers.
2025 decomposition: adj R-sq 0.696 -> 0.712, coef 1.83, p = 0.005 -
vs the raw-sum null (p = 0.30). Same data, better measurement.
CLI runs a three-way comparison; README/podcast notes/FPI sheet/deck
updated. Runs automatically in the 2026 preseason decomposition when
CFBD mirrors the inputs.

Co-Authored-By: Claude Fable 5 <noreply@anthropic.com>
</commit_message>
<xml_diff>
--- a/NCAA_FBS_Analytics_System.pptx
+++ b/NCAA_FBS_Analytics_System.pptx
@@ -4929,7 +4929,7 @@
                 </a:solidFill>
                 <a:latin typeface="Arial"/>
               </a:rPr>
-              <a:t>The portal adds nothing </a:t>
+              <a:t>The portal: measurement decides </a:t>
             </a:r>
             <a:r>
               <a:rPr sz="1500" b="0" i="0">
@@ -4938,7 +4938,7 @@
                 </a:solidFill>
                 <a:latin typeface="Arial"/>
               </a:rPr>
-              <a:t>(p = 0.30): adjusted R² moved 0.6960 → 0.6962. For all the portal hysteria, raw transfer-rating sums explain none of how ESPN rates teams.</a:t>
+              <a:t>— RAW transfer-rating sums add nothing (p = 0.30; they measure churn). QUALITY-WEIGHTED portal value (above-replacement, diminishing returns) is significant: adj R² 0.696 → 0.712, p = 0.005.</a:t>
             </a:r>
           </a:p>
         </p:txBody>

</xml_diff>